<commit_message>
split midterm script across 4 speakers + q&a prep
</commit_message>
<xml_diff>
--- a/Team01_Midterm.pptx
+++ b/Team01_Midterm.pptx
@@ -304,49 +304,43 @@
           <a:p>
             <a:r>
               <a:rPr lang="en-US" dirty="0"/>
-              <a:t>Box 1. The decision (about 40 seconds)</a:t>
-            </a:r>
-          </a:p>
-          <a:p>
-            <a:r>
-              <a:rPr lang="en-US" dirty="0"/>
-              <a:t>- Our project asks whether learned indexes (LURN-d IN-deks-iz) still outperform traditional indexes on modern hardware.</a:t>
-            </a:r>
-          </a:p>
-          <a:p>
-            <a:r>
-              <a:rPr lang="en-US" dirty="0"/>
-              <a:t>- Every database lookup must decide where a key is stored in a sorted array. Today, a B+tree (bee-plus tree) makes this decision through a sequence of comparisons.</a:t>
-            </a:r>
-          </a:p>
-          <a:p>
-            <a:r>
-              <a:rPr lang="en-US" dirty="0"/>
-              <a:t>- A poor decision does not return an incorrect result. However, it costs additional cache misses, and each miss to main memory costs approximately one hundred nanoseconds (NAN-oh-sek-unds).</a:t>
-            </a:r>
-          </a:p>
-          <a:p>
-            <a:r>
-              <a:rPr lang="en-US" dirty="0"/>
               <a:t/>
             </a:r>
           </a:p>
           <a:p>
             <a:r>
               <a:rPr lang="en-US" dirty="0"/>
-              <a:t>Box 2. The baseline (about 30 seconds)</a:t>
-            </a:r>
-          </a:p>
-          <a:p>
-            <a:r>
-              <a:rPr lang="en-US" dirty="0"/>
-              <a:t>- Our first baseline is binary search over the sorted array, using the standard library function lower_bound (LOH-er bound) with full compiler optimization. This is the reference baseline in the SOSD (ess-oh-ess-dee) benchmark.</a:t>
-            </a:r>
-          </a:p>
-          <a:p>
-            <a:r>
-              <a:rPr lang="en-US" dirty="0"/>
-              <a:t>- On our test machine, binary search requires 525 nanoseconds per lookup at one hundred million keys. A tuned B+tree and a hash table will be added as further baselines in the next phase.</a:t>
+              <a:t>1. Vishakha: boxes 1 and 2 (about 1 minute 15 seconds)</a:t>
+            </a:r>
+          </a:p>
+          <a:p>
+            <a:r>
+              <a:rPr lang="en-US" dirty="0"/>
+              <a:t>- Hello everyone. We are Team 1, and our project asks whether learned indexes (LURND IN-dek-siz) still outperform traditional indexes on modern hardware.</a:t>
+            </a:r>
+          </a:p>
+          <a:p>
+            <a:r>
+              <a:rPr lang="en-US" dirty="0"/>
+              <a:t>- Every database lookup must decide where a key is stored in a sorted array. Today, this decision is made by a B+tree (bee-plus tree), which follows a sequence of comparisons from the root to a leaf.</a:t>
+            </a:r>
+          </a:p>
+          <a:p>
+            <a:r>
+              <a:rPr lang="en-US" dirty="0"/>
+              <a:t>- A poor decision never returns an incorrect result. However, each additional step can cause a cache miss, and each miss to main memory costs approximately one hundred nanoseconds (NAN-oh-sek-unds).</a:t>
+            </a:r>
+          </a:p>
+          <a:p>
+            <a:r>
+              <a:rPr lang="en-US" dirty="0"/>
+              <a:t>- The baseline we must beat is binary search over the sorted array, implemented with the standard library function lower_bound (LOH-er bound) and compiled with full optimization. This is the reference baseline in the SOSD (ess-oh-ess-dee) benchmark. On our test machine, it requires 525 nanoseconds per lookup at one hundred million keys.</a:t>
+            </a:r>
+          </a:p>
+          <a:p>
+            <a:r>
+              <a:rPr lang="en-US" dirty="0"/>
+              <a:t>- A tuned B+tree and a hash table will be added as baselines in the next phase. I will now hand over to Riyon, who will explain our approach.</a:t>
             </a:r>
           </a:p>
           <a:p>
@@ -358,25 +352,31 @@
           <a:p>
             <a:r>
               <a:rPr lang="en-US" dirty="0"/>
-              <a:t>Box 3. Our approach (about 40 seconds)</a:t>
-            </a:r>
-          </a:p>
-          <a:p>
-            <a:r>
-              <a:rPr lang="en-US" dirty="0"/>
-              <a:t>- A learned index replaces the tree with a model that predicts the position of a key. We will evaluate four designs: the Recursive Model Index, or RMI (ar-em-eye), the PGM-index (pee-jee-em), RadixSpline (RAY-diks-spline), and ALEX (AL-eks).</a:t>
-            </a:r>
-          </a:p>
-          <a:p>
-            <a:r>
-              <a:rPr lang="en-US" dirty="0"/>
-              <a:t>- The training labels are free, because they are simply the positions of the keys in the sorted array.</a:t>
-            </a:r>
-          </a:p>
-          <a:p>
-            <a:r>
-              <a:rPr lang="en-US" dirty="0"/>
-              <a:t>- One inference costs a few multiply-add operations, followed by a local search inside a stored error bound. The result is therefore always exact.</a:t>
+              <a:t>2. Riyon: box 3 (about 1 minute)</a:t>
+            </a:r>
+          </a:p>
+          <a:p>
+            <a:r>
+              <a:rPr lang="en-US" dirty="0"/>
+              <a:t>- A learned index replaces the tree with a model. The model learns the relationship between each key and its position in the sorted array, and it predicts where a key should be.</a:t>
+            </a:r>
+          </a:p>
+          <a:p>
+            <a:r>
+              <a:rPr lang="en-US" dirty="0"/>
+              <a:t>- We will evaluate four designs: the Recursive Model Index, or RMI (ar-em-eye), the PGM-index (pee-jee-em), RadixSpline (RAY-diks-spline), and ALEX (AL-eks), which also supports inserts.</a:t>
+            </a:r>
+          </a:p>
+          <a:p>
+            <a:r>
+              <a:rPr lang="en-US" dirty="0"/>
+              <a:t>- An important advantage is that the training labels are free, because they are simply the positions of the keys in the sorted array.</a:t>
+            </a:r>
+          </a:p>
+          <a:p>
+            <a:r>
+              <a:rPr lang="en-US" dirty="0"/>
+              <a:t>- One inference costs only a few multiply-add operations. The model also stores its maximum error, so the final step is a small local search inside that error bound, and the result is always exact. Khang will now present our first result.</a:t>
             </a:r>
           </a:p>
           <a:p>
@@ -388,25 +388,25 @@
           <a:p>
             <a:r>
               <a:rPr lang="en-US" dirty="0"/>
-              <a:t>Box 4. First result (about 90 seconds)</a:t>
-            </a:r>
-          </a:p>
-          <a:p>
-            <a:r>
-              <a:rPr lang="en-US" dirty="0"/>
-              <a:t>- For the first result, we implemented a two-stage linear RMI, following Kraska (KRAS-kah) and colleagues. We compared it with binary search on two synthetic key distributions, uniform and lognormal (log-NOR-mul), from one hundred thousand to one hundred million keys.</a:t>
-            </a:r>
-          </a:p>
-          <a:p>
-            <a:r>
-              <a:rPr lang="en-US" dirty="0"/>
-              <a:t>- The horizontal axis shows the number of keys on a logarithmic (log-uh-RITH-mik) scale, and the vertical axis shows the median lookup latency. The dashed lines are the binary search baseline. The solid lines are the RMI, using the best of four model sizes at each point.</a:t>
-            </a:r>
-          </a:p>
-          <a:p>
-            <a:r>
-              <a:rPr lang="en-US" dirty="0"/>
-              <a:t>- Binary search slows down sharply once the data exceeds the 16-megabyte L3 (el-three) cache, because each lookup must then wait on main memory several times.</a:t>
+              <a:t>3. Khang: box 4 (about 1 minute 50 seconds)</a:t>
+            </a:r>
+          </a:p>
+          <a:p>
+            <a:r>
+              <a:rPr lang="en-US" dirty="0"/>
+              <a:t>- For our first result, we implemented a two-stage linear RMI, following the original paper by Kraska (KRAS-kah) and colleagues, and compared it with binary search. We used two synthetic key distributions, uniform and lognormal (log-NOR-mul), from one hundred thousand to one hundred million keys.</a:t>
+            </a:r>
+          </a:p>
+          <a:p>
+            <a:r>
+              <a:rPr lang="en-US" dirty="0"/>
+              <a:t>- The horizontal axis shows the number of keys on a logarithmic (log-uh-RITH-mik) scale, and the vertical axis shows the median lookup latency in nanoseconds. The dashed lines are the binary search baseline. The solid lines are the RMI, using the best of four model sizes at each point.</a:t>
+            </a:r>
+          </a:p>
+          <a:p>
+            <a:r>
+              <a:rPr lang="en-US" dirty="0"/>
+              <a:t>- Binary search slows down sharply after the dotted line, where the data no longer fits in the 16-megabyte L3 (el-three) cache. Beyond that point, each lookup must wait on main memory several times.</a:t>
             </a:r>
           </a:p>
           <a:p>
@@ -418,7 +418,7 @@
           <a:p>
             <a:r>
               <a:rPr lang="en-US" dirty="0"/>
-              <a:t>- All measurements were taken on an AMD Ryzen (RY-zen) AI 7 350 laptop processor, with the thread pinned to a single core. Each point is the median of five runs of two million random lookups, after one warm-up run.</a:t>
+              <a:t>- All measurements were taken on an AMD Ryzen (RY-zen) AI 7 350 laptop processor. Each point is the median of five runs of two million random lookups, after a warm-up run. This processor combines two types of cores. Without pinning the thread to one core, the results were about ten percent slower and noticeably noisier, so every run is now pinned. Sevara will now discuss what surprised us.</a:t>
             </a:r>
           </a:p>
           <a:p>
@@ -430,31 +430,37 @@
           <a:p>
             <a:r>
               <a:rPr lang="en-US" dirty="0"/>
-              <a:t>Box 5. What surprised us (about 90 seconds)</a:t>
-            </a:r>
-          </a:p>
-          <a:p>
-            <a:r>
-              <a:rPr lang="en-US" dirty="0"/>
-              <a:t>- The most important observation concerns the key distribution. With the same 2.3-megabyte model at one hundred million keys, lognormal lookups required 226 nanoseconds, compared with 81 nanoseconds for uniform keys.</a:t>
-            </a:r>
-          </a:p>
-          <a:p>
-            <a:r>
-              <a:rPr lang="en-US" dirty="0"/>
-              <a:t>- With a very small model of 58 kilobytes at ten million keys, the RMI was in fact slower than binary search, at 341 compared with 314 nanoseconds. A linear model cannot follow a skewed distribution, so the error window, and therefore the local search, becomes large.</a:t>
-            </a:r>
-          </a:p>
-          <a:p>
-            <a:r>
-              <a:rPr lang="en-US" dirty="0"/>
-              <a:t>- This taught us that results on uniform data overstate the benefit. The real datasets in SOSD, and the PGM-index and RadixSpline, which adapt better to skew, are therefore central to the next phase.</a:t>
-            </a:r>
-          </a:p>
-          <a:p>
-            <a:r>
-              <a:rPr lang="en-US" dirty="0"/>
-              <a:t>- We also encountered a measurement problem. This processor combines two types of cores. Without pinning the thread to one core, the results were about ten percent slower and considerably noisier. We now pin every run, add a warm-up period, and report the spread.</a:t>
+              <a:t>4. Sevara: boxes 5 and 6, gate check, closing (about 1 minute 55 seconds)</a:t>
+            </a:r>
+          </a:p>
+          <a:p>
+            <a:r>
+              <a:rPr lang="en-US" dirty="0"/>
+              <a:t>- The most surprising observation concerns the key distribution. With the same 2.3-megabyte model at one hundred million keys, lognormal lookups required 226 nanoseconds, compared with 81 nanoseconds for uniform keys.</a:t>
+            </a:r>
+          </a:p>
+          <a:p>
+            <a:r>
+              <a:rPr lang="en-US" dirty="0"/>
+              <a:t>- With a very small model of 58 kilobytes at ten million keys, the RMI was in fact slower than binary search, at 341 compared with 314 nanoseconds. A simple linear model cannot follow a skewed distribution, so the error window, and therefore the local search, becomes large. Results on uniform data therefore overstate the benefit.</a:t>
+            </a:r>
+          </a:p>
+          <a:p>
+            <a:r>
+              <a:rPr lang="en-US" dirty="0"/>
+              <a:t>- Over the next six weeks, the experiment that decides the project is the full SOSD benchmark on four real datasets, with hardware performance counters, on AMD, Intel, and ARM processors. The main risk is that the Linux perf (purf) tool cannot read hardware counters inside WSL2 (dub-ul-yoo ess el two) or on macOS. Our fallback is to rent bare-metal (bair-MET-ul) cloud machines on AWS.</a:t>
+            </a:r>
+          </a:p>
+          <a:p>
+            <a:r>
+              <a:rPr lang="en-US" dirty="0"/>
+              <a:t>- For the gate check, a wrong prediction is safe because the search is bounded, the labels are free, and the model uses about 0.3 percent of the data size. We are still unsure whether we beat a tuned baseline, because the B+tree is not yet integrated, and whether the approach survives new workloads, because inserts have not been tested.</a:t>
+            </a:r>
+          </a:p>
+          <a:p>
+            <a:r>
+              <a:rPr lang="en-US" dirty="0"/>
+              <a:t>- We would like to close with a question for the class: for the remaining weeks, should we prioritize more real datasets, or insert-heavy workloads with ALEX? Thank you.</a:t>
             </a:r>
           </a:p>
           <a:p>
@@ -466,61 +472,7 @@
           <a:p>
             <a:r>
               <a:rPr lang="en-US" dirty="0"/>
-              <a:t>Box 6. Next six weeks (about 40 seconds)</a:t>
-            </a:r>
-          </a:p>
-          <a:p>
-            <a:r>
-              <a:rPr lang="en-US" dirty="0"/>
-              <a:t>- The experiment that decides the project is the full SOSD benchmark on four real datasets, with hardware performance counters, on AMD, Intel, and ARM processors.</a:t>
-            </a:r>
-          </a:p>
-          <a:p>
-            <a:r>
-              <a:rPr lang="en-US" dirty="0"/>
-              <a:t>- The main risk is access to these counters. The Linux perf (purf) tool generally cannot read hardware counters inside WSL2 (dub-ul-yoo ess el two), and it does not exist on macOS. Our fallback is to rent bare-metal (bair-MET-ul) cloud instances on AWS for these runs.</a:t>
-            </a:r>
-          </a:p>
-          <a:p>
-            <a:r>
-              <a:rPr lang="en-US" dirty="0"/>
-              <a:t/>
-            </a:r>
-          </a:p>
-          <a:p>
-            <a:r>
-              <a:rPr lang="en-US" dirty="0"/>
-              <a:t>Gate check (about 20 seconds)</a:t>
-            </a:r>
-          </a:p>
-          <a:p>
-            <a:r>
-              <a:rPr lang="en-US" dirty="0"/>
-              <a:t>- A wrong prediction is safe, because the search is bounded, and the labels are free. The model also fits the budget, at about 0.3 percent of the data size.</a:t>
-            </a:r>
-          </a:p>
-          <a:p>
-            <a:r>
-              <a:rPr lang="en-US" dirty="0"/>
-              <a:t>- We are unsure whether we beat a tuned baseline, because the B+tree is not yet integrated. We are also unsure about new workloads, because inserts have not been tested yet.</a:t>
-            </a:r>
-          </a:p>
-          <a:p>
-            <a:r>
-              <a:rPr lang="en-US" dirty="0"/>
-              <a:t/>
-            </a:r>
-          </a:p>
-          <a:p>
-            <a:r>
-              <a:rPr lang="en-US" dirty="0"/>
-              <a:t>Closing question (then wait for an answer)</a:t>
-            </a:r>
-          </a:p>
-          <a:p>
-            <a:r>
-              <a:rPr lang="en-US" dirty="0"/>
-              <a:t>- Our question for the class is the following: for the remaining weeks, should we prioritize more real datasets, or insert-heavy workloads with ALEX?</a:t>
+              <a:t>Q&amp;A: see midterm_script.md in the repo for likely questions and who answers first.</a:t>
             </a:r>
           </a:p>
         </p:txBody>

</xml_diff>

<commit_message>
midterm script back to 1 presenter
</commit_message>
<xml_diff>
--- a/Team01_Midterm.pptx
+++ b/Team01_Midterm.pptx
@@ -310,7 +310,7 @@
           <a:p>
             <a:r>
               <a:rPr lang="en-US" dirty="0"/>
-              <a:t>1. Vishakha: boxes 1 and 2 (about 1 minute 15 seconds)</a:t>
+              <a:t>Box 1. The decision (about 40 seconds)</a:t>
             </a:r>
           </a:p>
           <a:p>
@@ -334,25 +334,37 @@
           <a:p>
             <a:r>
               <a:rPr lang="en-US" dirty="0"/>
-              <a:t>- The baseline we must beat is binary search over the sorted array, implemented with the standard library function lower_bound (LOH-er bound) and compiled with full optimization. This is the reference baseline in the SOSD (ess-oh-ess-dee) benchmark. On our test machine, it requires 525 nanoseconds per lookup at one hundred million keys.</a:t>
-            </a:r>
-          </a:p>
-          <a:p>
-            <a:r>
-              <a:rPr lang="en-US" dirty="0"/>
-              <a:t>- A tuned B+tree and a hash table will be added as baselines in the next phase. I will now hand over to Riyon, who will explain our approach.</a:t>
-            </a:r>
-          </a:p>
-          <a:p>
-            <a:r>
-              <a:rPr lang="en-US" dirty="0"/>
               <a:t/>
             </a:r>
           </a:p>
           <a:p>
             <a:r>
               <a:rPr lang="en-US" dirty="0"/>
-              <a:t>2. Riyon: box 3 (about 1 minute)</a:t>
+              <a:t>Box 2. Beat what, exactly? (about 35 seconds)</a:t>
+            </a:r>
+          </a:p>
+          <a:p>
+            <a:r>
+              <a:rPr lang="en-US" dirty="0"/>
+              <a:t>- The baseline we must beat is binary search over the sorted array, implemented with the standard library function lower_bound (LOH-er bound) and compiled with full optimization. This is the reference baseline in the SOSD (ess-oh-ess-dee) benchmark.</a:t>
+            </a:r>
+          </a:p>
+          <a:p>
+            <a:r>
+              <a:rPr lang="en-US" dirty="0"/>
+              <a:t>- On our test machine, binary search requires 525 nanoseconds per lookup at one hundred million keys. A tuned B+tree and a hash table will be added as baselines in the next phase.</a:t>
+            </a:r>
+          </a:p>
+          <a:p>
+            <a:r>
+              <a:rPr lang="en-US" dirty="0"/>
+              <a:t/>
+            </a:r>
+          </a:p>
+          <a:p>
+            <a:r>
+              <a:rPr lang="en-US" dirty="0"/>
+              <a:t>Box 3. Our approach (about 45 seconds)</a:t>
             </a:r>
           </a:p>
           <a:p>
@@ -370,13 +382,7 @@
           <a:p>
             <a:r>
               <a:rPr lang="en-US" dirty="0"/>
-              <a:t>- An important advantage is that the training labels are free, because they are simply the positions of the keys in the sorted array.</a:t>
-            </a:r>
-          </a:p>
-          <a:p>
-            <a:r>
-              <a:rPr lang="en-US" dirty="0"/>
-              <a:t>- One inference costs only a few multiply-add operations. The model also stores its maximum error, so the final step is a small local search inside that error bound, and the result is always exact. Khang will now present our first result.</a:t>
+              <a:t>- The training labels are free, because they are simply the positions of the keys. One inference costs only a few multiply-add operations, followed by a small local search inside a stored error bound, so the result is always exact.</a:t>
             </a:r>
           </a:p>
           <a:p>
@@ -388,7 +394,7 @@
           <a:p>
             <a:r>
               <a:rPr lang="en-US" dirty="0"/>
-              <a:t>3. Khang: box 4 (about 1 minute 50 seconds)</a:t>
+              <a:t>Box 4. First result (about 1 minute 40 seconds)</a:t>
             </a:r>
           </a:p>
           <a:p>
@@ -418,7 +424,7 @@
           <a:p>
             <a:r>
               <a:rPr lang="en-US" dirty="0"/>
-              <a:t>- All measurements were taken on an AMD Ryzen (RY-zen) AI 7 350 laptop processor. Each point is the median of five runs of two million random lookups, after a warm-up run. This processor combines two types of cores. Without pinning the thread to one core, the results were about ten percent slower and noticeably noisier, so every run is now pinned. Sevara will now discuss what surprised us.</a:t>
+              <a:t>- All measurements were taken on an AMD Ryzen (RY-zen) AI 7 350 laptop processor. Each point is the median of five runs of two million random lookups, after a warm-up run.</a:t>
             </a:r>
           </a:p>
           <a:p>
@@ -430,7 +436,7 @@
           <a:p>
             <a:r>
               <a:rPr lang="en-US" dirty="0"/>
-              <a:t>4. Sevara: boxes 5 and 6, gate check, closing (about 1 minute 55 seconds)</a:t>
+              <a:t>Box 5. What surprised us (about 1 minute 20 seconds)</a:t>
             </a:r>
           </a:p>
           <a:p>
@@ -448,13 +454,49 @@
           <a:p>
             <a:r>
               <a:rPr lang="en-US" dirty="0"/>
-              <a:t>- Over the next six weeks, the experiment that decides the project is the full SOSD benchmark on four real datasets, with hardware performance counters, on AMD, Intel, and ARM processors. The main risk is that the Linux perf (purf) tool cannot read hardware counters inside WSL2 (dub-ul-yoo ess el two) or on macOS. Our fallback is to rent bare-metal (bair-MET-ul) cloud machines on AWS.</a:t>
-            </a:r>
-          </a:p>
-          <a:p>
-            <a:r>
-              <a:rPr lang="en-US" dirty="0"/>
-              <a:t>- For the gate check, a wrong prediction is safe because the search is bounded, the labels are free, and the model uses about 0.3 percent of the data size. We are still unsure whether we beat a tuned baseline, because the B+tree is not yet integrated, and whether the approach survives new workloads, because inserts have not been tested.</a:t>
+              <a:t>- We also encountered a measurement problem. This processor combines two types of cores. Without pinning the thread to one core, the results were about ten percent slower and noticeably noisier, so every run is now pinned.</a:t>
+            </a:r>
+          </a:p>
+          <a:p>
+            <a:r>
+              <a:rPr lang="en-US" dirty="0"/>
+              <a:t/>
+            </a:r>
+          </a:p>
+          <a:p>
+            <a:r>
+              <a:rPr lang="en-US" dirty="0"/>
+              <a:t>Box 6. Next six weeks (about 40 seconds)</a:t>
+            </a:r>
+          </a:p>
+          <a:p>
+            <a:r>
+              <a:rPr lang="en-US" dirty="0"/>
+              <a:t>- The experiment that decides the project is the full SOSD benchmark on four real datasets, with hardware performance counters, on AMD, Intel, and ARM processors.</a:t>
+            </a:r>
+          </a:p>
+          <a:p>
+            <a:r>
+              <a:rPr lang="en-US" dirty="0"/>
+              <a:t>- The main risk is that the Linux perf (purf) tool cannot read hardware counters inside WSL2 (dub-ul-yoo ess el two) or on macOS. Our fallback is to rent bare-metal (bair-MET-ul) cloud machines on AWS.</a:t>
+            </a:r>
+          </a:p>
+          <a:p>
+            <a:r>
+              <a:rPr lang="en-US" dirty="0"/>
+              <a:t/>
+            </a:r>
+          </a:p>
+          <a:p>
+            <a:r>
+              <a:rPr lang="en-US" dirty="0"/>
+              <a:t>Gate check and closing (about 30 seconds)</a:t>
+            </a:r>
+          </a:p>
+          <a:p>
+            <a:r>
+              <a:rPr lang="en-US" dirty="0"/>
+              <a:t>- A wrong prediction is safe because the search is bounded, the labels are free, and the model uses about 0.3 percent of the data size. We are still unsure whether we beat a tuned baseline, because the B+tree is not yet integrated, and whether the approach survives new workloads, because inserts have not been tested.</a:t>
             </a:r>
           </a:p>
           <a:p>
@@ -472,7 +514,7 @@
           <a:p>
             <a:r>
               <a:rPr lang="en-US" dirty="0"/>
-              <a:t>Q&amp;A: see midterm_script.md in the repo for likely questions and who answers first.</a:t>
+              <a:t>Q&amp;A: see midterm_script.md in the repo for likely questions and short answers.</a:t>
             </a:r>
           </a:p>
         </p:txBody>

</xml_diff>